<commit_message>
feat(entregables/plan-ppt): diferencia las laminas de seccion con tipografia y acento
</commit_message>
<xml_diff>
--- a/api/inst/plantillas/plantilla_acnur_16_9.pptx
+++ b/api/inst/plantillas/plantilla_acnur_16_9.pptx
@@ -13632,6 +13632,38 @@
           </a:prstGeom>
         </p:spPr>
       </p:pic>
+      <p:sp xmlns:p="http://schemas.openxmlformats.org/presentationml/2006/main" xmlns:a="http://schemas.openxmlformats.org/drawingml/2006/main">
+        <p:nvSpPr>
+          <p:cNvPr id="220" name="prosecnur:section:accent"/>
+          <p:cNvSpPr/>
+          <p:nvPr userDrawn="1"/>
+        </p:nvSpPr>
+        <p:spPr>
+          <a:xfrm>
+            <a:off x="740664" y="2686050"/>
+            <a:ext cx="118872" cy="1005840"/>
+          </a:xfrm>
+          <a:prstGeom prst="roundRect">
+            <a:avLst>
+              <a:gd name="adj" fmla="val 50000"/>
+            </a:avLst>
+          </a:prstGeom>
+          <a:solidFill>
+            <a:srgbClr val="0072BC"/>
+          </a:solidFill>
+          <a:ln>
+            <a:noFill/>
+          </a:ln>
+        </p:spPr>
+        <p:txBody>
+          <a:bodyPr rtlCol="0" anchor="ctr"/>
+          <a:lstStyle/>
+          <a:p>
+            <a:pPr algn="ctr"/>
+            <a:endParaRPr lang="en-US"/>
+          </a:p>
+        </p:txBody>
+      </p:sp>
     </p:spTree>
     <p:extLst>
       <p:ext uri="{BB962C8B-B14F-4D97-AF65-F5344CB8AC3E}">

</xml_diff>